<commit_message>
[08312026] Created presentations for phase 1 - 01 -09
</commit_message>
<xml_diff>
--- a/learning/phase1-starter/01-rade-success-blueprint/presentation/rade-success-blueprint-summary.pptx
+++ b/learning/phase1-starter/01-rade-success-blueprint/presentation/rade-success-blueprint-summary.pptx
@@ -23,6 +23,7 @@
     <p:sldId id="271" r:id="rId22"/>
     <p:sldId id="272" r:id="rId23"/>
     <p:sldId id="273" r:id="rId24"/>
+    <p:sldId id="274" r:id="rId25"/>
   </p:sldIdLst>
   <p:sldSz cx="12191695" cy="6858000" type="screen4x3"/>
   <p:notesSz cx="6858000" cy="9144000"/>
@@ -11953,6 +11954,1046 @@
 </p:sld>
 </file>
 
+<file path=ppt/slides/slide19.xml><?xml version="1.0" encoding="utf-8"?>
+<p:sld xmlns:a="http://schemas.openxmlformats.org/drawingml/2006/main" xmlns:p="http://schemas.openxmlformats.org/presentationml/2006/main" xmlns:r="http://schemas.openxmlformats.org/officeDocument/2006/relationships">
+  <p:cSld>
+    <p:spTree>
+      <p:nvGrpSpPr>
+        <p:cNvPr id="1" name=""/>
+        <p:cNvGrpSpPr/>
+        <p:nvPr/>
+      </p:nvGrpSpPr>
+      <p:grpSpPr/>
+      <p:sp>
+        <p:nvSpPr>
+          <p:cNvPr id="2" name="Rectangle 1"/>
+          <p:cNvSpPr/>
+          <p:nvPr/>
+        </p:nvSpPr>
+        <p:spPr>
+          <a:xfrm>
+            <a:off x="0" y="0"/>
+            <a:ext cx="12191695" cy="164592"/>
+          </a:xfrm>
+          <a:prstGeom prst="rect">
+            <a:avLst/>
+          </a:prstGeom>
+          <a:solidFill>
+            <a:srgbClr val="00A7A5"/>
+          </a:solidFill>
+          <a:ln>
+            <a:solidFill>
+              <a:srgbClr val="00A7A5"/>
+            </a:solidFill>
+          </a:ln>
+        </p:spPr>
+        <p:style>
+          <a:lnRef idx="1">
+            <a:schemeClr val="accent1"/>
+          </a:lnRef>
+          <a:fillRef idx="3">
+            <a:schemeClr val="accent1"/>
+          </a:fillRef>
+          <a:effectRef idx="2">
+            <a:schemeClr val="accent1"/>
+          </a:effectRef>
+          <a:fontRef idx="minor">
+            <a:schemeClr val="lt1"/>
+          </a:fontRef>
+        </p:style>
+        <p:txBody>
+          <a:bodyPr rtlCol="0" anchor="ctr"/>
+          <a:lstStyle/>
+          <a:p>
+            <a:pPr algn="ctr"/>
+          </a:p>
+        </p:txBody>
+      </p:sp>
+      <p:sp>
+        <p:nvSpPr>
+          <p:cNvPr id="3" name="TextBox 2"/>
+          <p:cNvSpPr txBox="1"/>
+          <p:nvPr/>
+        </p:nvSpPr>
+        <p:spPr>
+          <a:xfrm>
+            <a:off x="594360" y="347472"/>
+            <a:ext cx="3108960" cy="310896"/>
+          </a:xfrm>
+          <a:prstGeom prst="rect">
+            <a:avLst/>
+          </a:prstGeom>
+          <a:noFill/>
+        </p:spPr>
+        <p:txBody>
+          <a:bodyPr wrap="square" lIns="27432" rIns="27432" tIns="27432" bIns="27432" anchor="t">
+            <a:spAutoFit/>
+          </a:bodyPr>
+          <a:lstStyle/>
+          <a:p>
+            <a:pPr algn="l">
+              <a:spcBef>
+                <a:spcPts val="0"/>
+              </a:spcBef>
+              <a:spcAft>
+                <a:spcPts val="0"/>
+              </a:spcAft>
+            </a:pPr>
+            <a:r>
+              <a:rPr sz="1000" b="1">
+                <a:solidFill>
+                  <a:srgbClr val="00A7A5"/>
+                </a:solidFill>
+                <a:latin typeface="Aptos"/>
+              </a:rPr>
+              <a:t>SOURCE INDEX</a:t>
+            </a:r>
+          </a:p>
+        </p:txBody>
+      </p:sp>
+      <p:sp>
+        <p:nvSpPr>
+          <p:cNvPr id="4" name="TextBox 3"/>
+          <p:cNvSpPr txBox="1"/>
+          <p:nvPr/>
+        </p:nvSpPr>
+        <p:spPr>
+          <a:xfrm>
+            <a:off x="594360" y="713232"/>
+            <a:ext cx="10287000" cy="566928"/>
+          </a:xfrm>
+          <a:prstGeom prst="rect">
+            <a:avLst/>
+          </a:prstGeom>
+          <a:noFill/>
+        </p:spPr>
+        <p:txBody>
+          <a:bodyPr wrap="square" lIns="27432" rIns="27432" tIns="27432" bIns="27432" anchor="t">
+            <a:spAutoFit/>
+          </a:bodyPr>
+          <a:lstStyle/>
+          <a:p>
+            <a:pPr algn="l">
+              <a:spcBef>
+                <a:spcPts val="0"/>
+              </a:spcBef>
+              <a:spcAft>
+                <a:spcPts val="0"/>
+              </a:spcAft>
+            </a:pPr>
+            <a:r>
+              <a:rPr sz="2900" b="1">
+                <a:solidFill>
+                  <a:srgbClr val="14233E"/>
+                </a:solidFill>
+                <a:latin typeface="Aptos"/>
+              </a:rPr>
+              <a:t>Source index and deliberate exclusions</a:t>
+            </a:r>
+          </a:p>
+        </p:txBody>
+      </p:sp>
+      <p:sp>
+        <p:nvSpPr>
+          <p:cNvPr id="5" name="TextBox 4"/>
+          <p:cNvSpPr txBox="1"/>
+          <p:nvPr/>
+        </p:nvSpPr>
+        <p:spPr>
+          <a:xfrm>
+            <a:off x="11109960" y="347472"/>
+            <a:ext cx="475488" cy="310896"/>
+          </a:xfrm>
+          <a:prstGeom prst="rect">
+            <a:avLst/>
+          </a:prstGeom>
+          <a:noFill/>
+        </p:spPr>
+        <p:txBody>
+          <a:bodyPr wrap="square" lIns="27432" rIns="27432" tIns="27432" bIns="27432" anchor="t">
+            <a:spAutoFit/>
+          </a:bodyPr>
+          <a:lstStyle/>
+          <a:p>
+            <a:pPr algn="r">
+              <a:spcBef>
+                <a:spcPts val="0"/>
+              </a:spcBef>
+              <a:spcAft>
+                <a:spcPts val="0"/>
+              </a:spcAft>
+            </a:pPr>
+            <a:r>
+              <a:rPr sz="1000" b="1">
+                <a:solidFill>
+                  <a:srgbClr val="14233E"/>
+                </a:solidFill>
+                <a:latin typeface="Aptos"/>
+              </a:rPr>
+              <a:t>19</a:t>
+            </a:r>
+          </a:p>
+        </p:txBody>
+      </p:sp>
+      <p:sp>
+        <p:nvSpPr>
+          <p:cNvPr id="6" name="Rounded Rectangle 5"/>
+          <p:cNvSpPr/>
+          <p:nvPr/>
+        </p:nvSpPr>
+        <p:spPr>
+          <a:xfrm>
+            <a:off x="594360" y="1417320"/>
+            <a:ext cx="5404104" cy="429768"/>
+          </a:xfrm>
+          <a:prstGeom prst="roundRect">
+            <a:avLst/>
+          </a:prstGeom>
+          <a:solidFill>
+            <a:srgbClr val="F4F7FA"/>
+          </a:solidFill>
+          <a:ln w="10160">
+            <a:solidFill>
+              <a:srgbClr val="D7E0EA"/>
+            </a:solidFill>
+          </a:ln>
+        </p:spPr>
+        <p:style>
+          <a:lnRef idx="1">
+            <a:schemeClr val="accent1"/>
+          </a:lnRef>
+          <a:fillRef idx="3">
+            <a:schemeClr val="accent1"/>
+          </a:fillRef>
+          <a:effectRef idx="2">
+            <a:schemeClr val="accent1"/>
+          </a:effectRef>
+          <a:fontRef idx="minor">
+            <a:schemeClr val="lt1"/>
+          </a:fontRef>
+        </p:style>
+        <p:txBody>
+          <a:bodyPr rtlCol="0" anchor="ctr" wrap="square" tIns="27432" bIns="27432"/>
+          <a:lstStyle/>
+          <a:p>
+            <a:pPr algn="l">
+              <a:spcBef>
+                <a:spcPts val="0"/>
+              </a:spcBef>
+              <a:spcAft>
+                <a:spcPts val="0"/>
+              </a:spcAft>
+            </a:pPr>
+            <a:r>
+              <a:rPr sz="900" b="0">
+                <a:solidFill>
+                  <a:srgbClr val="14233E"/>
+                </a:solidFill>
+                <a:latin typeface="Aptos"/>
+              </a:rPr>
+              <a:t>T01  01-1-welcome-to-deh-your-journey-begins-here-revisit.txt</a:t>
+            </a:r>
+          </a:p>
+        </p:txBody>
+      </p:sp>
+      <p:sp>
+        <p:nvSpPr>
+          <p:cNvPr id="7" name="Rounded Rectangle 6"/>
+          <p:cNvSpPr/>
+          <p:nvPr/>
+        </p:nvSpPr>
+        <p:spPr>
+          <a:xfrm>
+            <a:off x="594360" y="1956816"/>
+            <a:ext cx="5404104" cy="429768"/>
+          </a:xfrm>
+          <a:prstGeom prst="roundRect">
+            <a:avLst/>
+          </a:prstGeom>
+          <a:solidFill>
+            <a:srgbClr val="F4F7FA"/>
+          </a:solidFill>
+          <a:ln w="10160">
+            <a:solidFill>
+              <a:srgbClr val="D7E0EA"/>
+            </a:solidFill>
+          </a:ln>
+        </p:spPr>
+        <p:style>
+          <a:lnRef idx="1">
+            <a:schemeClr val="accent1"/>
+          </a:lnRef>
+          <a:fillRef idx="3">
+            <a:schemeClr val="accent1"/>
+          </a:fillRef>
+          <a:effectRef idx="2">
+            <a:schemeClr val="accent1"/>
+          </a:effectRef>
+          <a:fontRef idx="minor">
+            <a:schemeClr val="lt1"/>
+          </a:fontRef>
+        </p:style>
+        <p:txBody>
+          <a:bodyPr rtlCol="0" anchor="ctr" wrap="square" tIns="27432" bIns="27432"/>
+          <a:lstStyle/>
+          <a:p>
+            <a:pPr algn="l">
+              <a:spcBef>
+                <a:spcPts val="0"/>
+              </a:spcBef>
+              <a:spcAft>
+                <a:spcPts val="0"/>
+              </a:spcAft>
+            </a:pPr>
+            <a:r>
+              <a:rPr sz="900" b="0">
+                <a:solidFill>
+                  <a:srgbClr val="14233E"/>
+                </a:solidFill>
+                <a:latin typeface="Aptos"/>
+              </a:rPr>
+              <a:t>T02  02-2-how-the-program-works-system-levels-path-to-hof-revisit.txt</a:t>
+            </a:r>
+          </a:p>
+        </p:txBody>
+      </p:sp>
+      <p:sp>
+        <p:nvSpPr>
+          <p:cNvPr id="8" name="Rounded Rectangle 7"/>
+          <p:cNvSpPr/>
+          <p:nvPr/>
+        </p:nvSpPr>
+        <p:spPr>
+          <a:xfrm>
+            <a:off x="594360" y="2496312"/>
+            <a:ext cx="5404104" cy="429768"/>
+          </a:xfrm>
+          <a:prstGeom prst="roundRect">
+            <a:avLst/>
+          </a:prstGeom>
+          <a:solidFill>
+            <a:srgbClr val="F4F7FA"/>
+          </a:solidFill>
+          <a:ln w="10160">
+            <a:solidFill>
+              <a:srgbClr val="D7E0EA"/>
+            </a:solidFill>
+          </a:ln>
+        </p:spPr>
+        <p:style>
+          <a:lnRef idx="1">
+            <a:schemeClr val="accent1"/>
+          </a:lnRef>
+          <a:fillRef idx="3">
+            <a:schemeClr val="accent1"/>
+          </a:fillRef>
+          <a:effectRef idx="2">
+            <a:schemeClr val="accent1"/>
+          </a:effectRef>
+          <a:fontRef idx="minor">
+            <a:schemeClr val="lt1"/>
+          </a:fontRef>
+        </p:style>
+        <p:txBody>
+          <a:bodyPr rtlCol="0" anchor="ctr" wrap="square" tIns="27432" bIns="27432"/>
+          <a:lstStyle/>
+          <a:p>
+            <a:pPr algn="l">
+              <a:spcBef>
+                <a:spcPts val="0"/>
+              </a:spcBef>
+              <a:spcAft>
+                <a:spcPts val="0"/>
+              </a:spcAft>
+            </a:pPr>
+            <a:r>
+              <a:rPr sz="900" b="0">
+                <a:solidFill>
+                  <a:srgbClr val="14233E"/>
+                </a:solidFill>
+                <a:latin typeface="Aptos"/>
+              </a:rPr>
+              <a:t>T03  03-3-from-confusion-to-clarity-real-student-transformations-revisit.txt</a:t>
+            </a:r>
+          </a:p>
+        </p:txBody>
+      </p:sp>
+      <p:sp>
+        <p:nvSpPr>
+          <p:cNvPr id="9" name="Rounded Rectangle 8"/>
+          <p:cNvSpPr/>
+          <p:nvPr/>
+        </p:nvSpPr>
+        <p:spPr>
+          <a:xfrm>
+            <a:off x="594360" y="3035808"/>
+            <a:ext cx="5404104" cy="429768"/>
+          </a:xfrm>
+          <a:prstGeom prst="roundRect">
+            <a:avLst/>
+          </a:prstGeom>
+          <a:solidFill>
+            <a:srgbClr val="F4F7FA"/>
+          </a:solidFill>
+          <a:ln w="10160">
+            <a:solidFill>
+              <a:srgbClr val="D7E0EA"/>
+            </a:solidFill>
+          </a:ln>
+        </p:spPr>
+        <p:style>
+          <a:lnRef idx="1">
+            <a:schemeClr val="accent1"/>
+          </a:lnRef>
+          <a:fillRef idx="3">
+            <a:schemeClr val="accent1"/>
+          </a:fillRef>
+          <a:effectRef idx="2">
+            <a:schemeClr val="accent1"/>
+          </a:effectRef>
+          <a:fontRef idx="minor">
+            <a:schemeClr val="lt1"/>
+          </a:fontRef>
+        </p:style>
+        <p:txBody>
+          <a:bodyPr rtlCol="0" anchor="ctr" wrap="square" tIns="27432" bIns="27432"/>
+          <a:lstStyle/>
+          <a:p>
+            <a:pPr algn="l">
+              <a:spcBef>
+                <a:spcPts val="0"/>
+              </a:spcBef>
+              <a:spcAft>
+                <a:spcPts val="0"/>
+              </a:spcAft>
+            </a:pPr>
+            <a:r>
+              <a:rPr sz="900" b="0">
+                <a:solidFill>
+                  <a:srgbClr val="14233E"/>
+                </a:solidFill>
+                <a:latin typeface="Aptos"/>
+              </a:rPr>
+              <a:t>T04  04-4-commitment-intention-the-game-of-skills-revisit.txt</a:t>
+            </a:r>
+          </a:p>
+        </p:txBody>
+      </p:sp>
+      <p:sp>
+        <p:nvSpPr>
+          <p:cNvPr id="10" name="Rounded Rectangle 9"/>
+          <p:cNvSpPr/>
+          <p:nvPr/>
+        </p:nvSpPr>
+        <p:spPr>
+          <a:xfrm>
+            <a:off x="594360" y="3575304"/>
+            <a:ext cx="5404104" cy="429768"/>
+          </a:xfrm>
+          <a:prstGeom prst="roundRect">
+            <a:avLst/>
+          </a:prstGeom>
+          <a:solidFill>
+            <a:srgbClr val="F4F7FA"/>
+          </a:solidFill>
+          <a:ln w="10160">
+            <a:solidFill>
+              <a:srgbClr val="D7E0EA"/>
+            </a:solidFill>
+          </a:ln>
+        </p:spPr>
+        <p:style>
+          <a:lnRef idx="1">
+            <a:schemeClr val="accent1"/>
+          </a:lnRef>
+          <a:fillRef idx="3">
+            <a:schemeClr val="accent1"/>
+          </a:fillRef>
+          <a:effectRef idx="2">
+            <a:schemeClr val="accent1"/>
+          </a:effectRef>
+          <a:fontRef idx="minor">
+            <a:schemeClr val="lt1"/>
+          </a:fontRef>
+        </p:style>
+        <p:txBody>
+          <a:bodyPr rtlCol="0" anchor="ctr" wrap="square" tIns="27432" bIns="27432"/>
+          <a:lstStyle/>
+          <a:p>
+            <a:pPr algn="l">
+              <a:spcBef>
+                <a:spcPts val="0"/>
+              </a:spcBef>
+              <a:spcAft>
+                <a:spcPts val="0"/>
+              </a:spcAft>
+            </a:pPr>
+            <a:r>
+              <a:rPr sz="900" b="0">
+                <a:solidFill>
+                  <a:srgbClr val="14233E"/>
+                </a:solidFill>
+                <a:latin typeface="Aptos"/>
+              </a:rPr>
+              <a:t>T05  05-1-the-journey-ahead-how-you-actually-become-highly-paid-revisit.txt</a:t>
+            </a:r>
+          </a:p>
+        </p:txBody>
+      </p:sp>
+      <p:sp>
+        <p:nvSpPr>
+          <p:cNvPr id="11" name="Rounded Rectangle 10"/>
+          <p:cNvSpPr/>
+          <p:nvPr/>
+        </p:nvSpPr>
+        <p:spPr>
+          <a:xfrm>
+            <a:off x="6190488" y="1417320"/>
+            <a:ext cx="5404104" cy="429768"/>
+          </a:xfrm>
+          <a:prstGeom prst="roundRect">
+            <a:avLst/>
+          </a:prstGeom>
+          <a:solidFill>
+            <a:srgbClr val="F4F7FA"/>
+          </a:solidFill>
+          <a:ln w="10160">
+            <a:solidFill>
+              <a:srgbClr val="D7E0EA"/>
+            </a:solidFill>
+          </a:ln>
+        </p:spPr>
+        <p:style>
+          <a:lnRef idx="1">
+            <a:schemeClr val="accent1"/>
+          </a:lnRef>
+          <a:fillRef idx="3">
+            <a:schemeClr val="accent1"/>
+          </a:fillRef>
+          <a:effectRef idx="2">
+            <a:schemeClr val="accent1"/>
+          </a:effectRef>
+          <a:fontRef idx="minor">
+            <a:schemeClr val="lt1"/>
+          </a:fontRef>
+        </p:style>
+        <p:txBody>
+          <a:bodyPr rtlCol="0" anchor="ctr" wrap="square" tIns="27432" bIns="27432"/>
+          <a:lstStyle/>
+          <a:p>
+            <a:pPr algn="l">
+              <a:spcBef>
+                <a:spcPts val="0"/>
+              </a:spcBef>
+              <a:spcAft>
+                <a:spcPts val="0"/>
+              </a:spcAft>
+            </a:pPr>
+            <a:r>
+              <a:rPr sz="900" b="0">
+                <a:solidFill>
+                  <a:srgbClr val="14233E"/>
+                </a:solidFill>
+                <a:latin typeface="Aptos"/>
+              </a:rPr>
+              <a:t>T06  06-2-self-discovery-assignment-revisit.txt</a:t>
+            </a:r>
+          </a:p>
+        </p:txBody>
+      </p:sp>
+      <p:sp>
+        <p:nvSpPr>
+          <p:cNvPr id="12" name="Rounded Rectangle 11"/>
+          <p:cNvSpPr/>
+          <p:nvPr/>
+        </p:nvSpPr>
+        <p:spPr>
+          <a:xfrm>
+            <a:off x="6190488" y="1956816"/>
+            <a:ext cx="5404104" cy="429768"/>
+          </a:xfrm>
+          <a:prstGeom prst="roundRect">
+            <a:avLst/>
+          </a:prstGeom>
+          <a:solidFill>
+            <a:srgbClr val="F4F7FA"/>
+          </a:solidFill>
+          <a:ln w="10160">
+            <a:solidFill>
+              <a:srgbClr val="D7E0EA"/>
+            </a:solidFill>
+          </a:ln>
+        </p:spPr>
+        <p:style>
+          <a:lnRef idx="1">
+            <a:schemeClr val="accent1"/>
+          </a:lnRef>
+          <a:fillRef idx="3">
+            <a:schemeClr val="accent1"/>
+          </a:fillRef>
+          <a:effectRef idx="2">
+            <a:schemeClr val="accent1"/>
+          </a:effectRef>
+          <a:fontRef idx="minor">
+            <a:schemeClr val="lt1"/>
+          </a:fontRef>
+        </p:style>
+        <p:txBody>
+          <a:bodyPr rtlCol="0" anchor="ctr" wrap="square" tIns="27432" bIns="27432"/>
+          <a:lstStyle/>
+          <a:p>
+            <a:pPr algn="l">
+              <a:spcBef>
+                <a:spcPts val="0"/>
+              </a:spcBef>
+              <a:spcAft>
+                <a:spcPts val="0"/>
+              </a:spcAft>
+            </a:pPr>
+            <a:r>
+              <a:rPr sz="900" b="0">
+                <a:solidFill>
+                  <a:srgbClr val="14233E"/>
+                </a:solidFill>
+                <a:latin typeface="Aptos"/>
+              </a:rPr>
+              <a:t>T07  07-3-set-your-goals-clarity-intentions-visualization-revisit.txt</a:t>
+            </a:r>
+          </a:p>
+        </p:txBody>
+      </p:sp>
+      <p:sp>
+        <p:nvSpPr>
+          <p:cNvPr id="13" name="Rounded Rectangle 12"/>
+          <p:cNvSpPr/>
+          <p:nvPr/>
+        </p:nvSpPr>
+        <p:spPr>
+          <a:xfrm>
+            <a:off x="6190488" y="2496312"/>
+            <a:ext cx="5404104" cy="429768"/>
+          </a:xfrm>
+          <a:prstGeom prst="roundRect">
+            <a:avLst/>
+          </a:prstGeom>
+          <a:solidFill>
+            <a:srgbClr val="F4F7FA"/>
+          </a:solidFill>
+          <a:ln w="10160">
+            <a:solidFill>
+              <a:srgbClr val="D7E0EA"/>
+            </a:solidFill>
+          </a:ln>
+        </p:spPr>
+        <p:style>
+          <a:lnRef idx="1">
+            <a:schemeClr val="accent1"/>
+          </a:lnRef>
+          <a:fillRef idx="3">
+            <a:schemeClr val="accent1"/>
+          </a:fillRef>
+          <a:effectRef idx="2">
+            <a:schemeClr val="accent1"/>
+          </a:effectRef>
+          <a:fontRef idx="minor">
+            <a:schemeClr val="lt1"/>
+          </a:fontRef>
+        </p:style>
+        <p:txBody>
+          <a:bodyPr rtlCol="0" anchor="ctr" wrap="square" tIns="27432" bIns="27432"/>
+          <a:lstStyle/>
+          <a:p>
+            <a:pPr algn="l">
+              <a:spcBef>
+                <a:spcPts val="0"/>
+              </a:spcBef>
+              <a:spcAft>
+                <a:spcPts val="0"/>
+              </a:spcAft>
+            </a:pPr>
+            <a:r>
+              <a:rPr sz="900" b="0">
+                <a:solidFill>
+                  <a:srgbClr val="14233E"/>
+                </a:solidFill>
+                <a:latin typeface="Aptos"/>
+              </a:rPr>
+              <a:t>T08  08-1-make-your-journey-foolproof-leverage-the-power-of-community-revisit.txt</a:t>
+            </a:r>
+          </a:p>
+        </p:txBody>
+      </p:sp>
+      <p:sp>
+        <p:nvSpPr>
+          <p:cNvPr id="14" name="Rounded Rectangle 13"/>
+          <p:cNvSpPr/>
+          <p:nvPr/>
+        </p:nvSpPr>
+        <p:spPr>
+          <a:xfrm>
+            <a:off x="6190488" y="3035808"/>
+            <a:ext cx="5404104" cy="429768"/>
+          </a:xfrm>
+          <a:prstGeom prst="roundRect">
+            <a:avLst/>
+          </a:prstGeom>
+          <a:solidFill>
+            <a:srgbClr val="F4F7FA"/>
+          </a:solidFill>
+          <a:ln w="10160">
+            <a:solidFill>
+              <a:srgbClr val="D7E0EA"/>
+            </a:solidFill>
+          </a:ln>
+        </p:spPr>
+        <p:style>
+          <a:lnRef idx="1">
+            <a:schemeClr val="accent1"/>
+          </a:lnRef>
+          <a:fillRef idx="3">
+            <a:schemeClr val="accent1"/>
+          </a:fillRef>
+          <a:effectRef idx="2">
+            <a:schemeClr val="accent1"/>
+          </a:effectRef>
+          <a:fontRef idx="minor">
+            <a:schemeClr val="lt1"/>
+          </a:fontRef>
+        </p:style>
+        <p:txBody>
+          <a:bodyPr rtlCol="0" anchor="ctr" wrap="square" tIns="27432" bIns="27432"/>
+          <a:lstStyle/>
+          <a:p>
+            <a:pPr algn="l">
+              <a:spcBef>
+                <a:spcPts val="0"/>
+              </a:spcBef>
+              <a:spcAft>
+                <a:spcPts val="0"/>
+              </a:spcAft>
+            </a:pPr>
+            <a:r>
+              <a:rPr sz="900" b="0">
+                <a:solidFill>
+                  <a:srgbClr val="14233E"/>
+                </a:solidFill>
+                <a:latin typeface="Aptos"/>
+              </a:rPr>
+              <a:t>T09  09-2-what-you-will-achieve-the-46-week-transformation-plan-resume.txt</a:t>
+            </a:r>
+          </a:p>
+        </p:txBody>
+      </p:sp>
+      <p:sp>
+        <p:nvSpPr>
+          <p:cNvPr id="15" name="Rounded Rectangle 14"/>
+          <p:cNvSpPr/>
+          <p:nvPr/>
+        </p:nvSpPr>
+        <p:spPr>
+          <a:xfrm>
+            <a:off x="6190488" y="3575304"/>
+            <a:ext cx="5404104" cy="429768"/>
+          </a:xfrm>
+          <a:prstGeom prst="roundRect">
+            <a:avLst/>
+          </a:prstGeom>
+          <a:solidFill>
+            <a:srgbClr val="F4F7FA"/>
+          </a:solidFill>
+          <a:ln w="10160">
+            <a:solidFill>
+              <a:srgbClr val="D7E0EA"/>
+            </a:solidFill>
+          </a:ln>
+        </p:spPr>
+        <p:style>
+          <a:lnRef idx="1">
+            <a:schemeClr val="accent1"/>
+          </a:lnRef>
+          <a:fillRef idx="3">
+            <a:schemeClr val="accent1"/>
+          </a:fillRef>
+          <a:effectRef idx="2">
+            <a:schemeClr val="accent1"/>
+          </a:effectRef>
+          <a:fontRef idx="minor">
+            <a:schemeClr val="lt1"/>
+          </a:fontRef>
+        </p:style>
+        <p:txBody>
+          <a:bodyPr rtlCol="0" anchor="ctr" wrap="square" tIns="27432" bIns="27432"/>
+          <a:lstStyle/>
+          <a:p>
+            <a:pPr algn="l">
+              <a:spcBef>
+                <a:spcPts val="0"/>
+              </a:spcBef>
+              <a:spcAft>
+                <a:spcPts val="0"/>
+              </a:spcAft>
+            </a:pPr>
+            <a:r>
+              <a:rPr sz="900" b="0">
+                <a:solidFill>
+                  <a:srgbClr val="14233E"/>
+                </a:solidFill>
+                <a:latin typeface="Aptos"/>
+              </a:rPr>
+              <a:t>T10  10-3-final-clarity-your-next-steps-moving-forward-resume.txt</a:t>
+            </a:r>
+          </a:p>
+        </p:txBody>
+      </p:sp>
+      <p:sp>
+        <p:nvSpPr>
+          <p:cNvPr id="16" name="Rounded Rectangle 15"/>
+          <p:cNvSpPr/>
+          <p:nvPr/>
+        </p:nvSpPr>
+        <p:spPr>
+          <a:xfrm>
+            <a:off x="594360" y="4251960"/>
+            <a:ext cx="10991088" cy="566928"/>
+          </a:xfrm>
+          <a:prstGeom prst="roundRect">
+            <a:avLst/>
+          </a:prstGeom>
+          <a:solidFill>
+            <a:srgbClr val="FFF3DA"/>
+          </a:solidFill>
+          <a:ln w="10160">
+            <a:solidFill>
+              <a:srgbClr val="E8A62D"/>
+            </a:solidFill>
+          </a:ln>
+        </p:spPr>
+        <p:style>
+          <a:lnRef idx="1">
+            <a:schemeClr val="accent1"/>
+          </a:lnRef>
+          <a:fillRef idx="3">
+            <a:schemeClr val="accent1"/>
+          </a:fillRef>
+          <a:effectRef idx="2">
+            <a:schemeClr val="accent1"/>
+          </a:effectRef>
+          <a:fontRef idx="minor">
+            <a:schemeClr val="lt1"/>
+          </a:fontRef>
+        </p:style>
+        <p:txBody>
+          <a:bodyPr rtlCol="0" anchor="ctr" wrap="square" lIns="146304" rIns="146304" tIns="27432" bIns="27432"/>
+          <a:lstStyle/>
+          <a:p>
+            <a:pPr algn="l">
+              <a:spcBef>
+                <a:spcPts val="0"/>
+              </a:spcBef>
+              <a:spcAft>
+                <a:spcPts val="0"/>
+              </a:spcAft>
+            </a:pPr>
+            <a:r>
+              <a:rPr sz="1120" b="1">
+                <a:solidFill>
+                  <a:srgbClr val="14233E"/>
+                </a:solidFill>
+                <a:latin typeface="Aptos"/>
+              </a:rPr>
+              <a:t>Commercial offers/vouchers and unverified causal or outcome claims were not carried forward as current guidance.</a:t>
+            </a:r>
+          </a:p>
+        </p:txBody>
+      </p:sp>
+      <p:sp>
+        <p:nvSpPr>
+          <p:cNvPr id="17" name="Rounded Rectangle 16"/>
+          <p:cNvSpPr/>
+          <p:nvPr/>
+        </p:nvSpPr>
+        <p:spPr>
+          <a:xfrm>
+            <a:off x="594360" y="4965192"/>
+            <a:ext cx="10991088" cy="804672"/>
+          </a:xfrm>
+          <a:prstGeom prst="roundRect">
+            <a:avLst/>
+          </a:prstGeom>
+          <a:solidFill>
+            <a:srgbClr val="E8F7F5"/>
+          </a:solidFill>
+          <a:ln w="10160">
+            <a:solidFill>
+              <a:srgbClr val="00A7A5"/>
+            </a:solidFill>
+          </a:ln>
+        </p:spPr>
+        <p:style>
+          <a:lnRef idx="1">
+            <a:schemeClr val="accent1"/>
+          </a:lnRef>
+          <a:fillRef idx="3">
+            <a:schemeClr val="accent1"/>
+          </a:fillRef>
+          <a:effectRef idx="2">
+            <a:schemeClr val="accent1"/>
+          </a:effectRef>
+          <a:fontRef idx="minor">
+            <a:schemeClr val="lt1"/>
+          </a:fontRef>
+        </p:style>
+        <p:txBody>
+          <a:bodyPr rtlCol="0" anchor="ctr" wrap="square" lIns="146304" rIns="146304" tIns="27432" bIns="27432"/>
+          <a:lstStyle/>
+          <a:p>
+            <a:pPr algn="l">
+              <a:spcBef>
+                <a:spcPts val="0"/>
+              </a:spcBef>
+              <a:spcAft>
+                <a:spcPts val="0"/>
+              </a:spcAft>
+            </a:pPr>
+            <a:r>
+              <a:rPr sz="1220" b="1">
+                <a:solidFill>
+                  <a:srgbClr val="14233E"/>
+                </a:solidFill>
+                <a:latin typeface="Aptos"/>
+              </a:rPr>
+              <a:t>90-day listening, brain-rewiring, and 80/20 assertions are instructor mindset claims, not verified evidence or the current 30-day supporting habit.</a:t>
+            </a:r>
+          </a:p>
+        </p:txBody>
+      </p:sp>
+      <p:cxnSp>
+        <p:nvCxnSpPr>
+          <p:cNvPr id="18" name="Connector 17"/>
+          <p:cNvCxnSpPr/>
+          <p:nvPr/>
+        </p:nvCxnSpPr>
+        <p:spPr>
+          <a:xfrm>
+            <a:off x="594360" y="6437376"/>
+            <a:ext cx="10991088" cy="0"/>
+          </a:xfrm>
+          <a:prstGeom prst="line">
+            <a:avLst/>
+          </a:prstGeom>
+          <a:ln w="10160">
+            <a:solidFill>
+              <a:srgbClr val="D7E0EA"/>
+            </a:solidFill>
+          </a:ln>
+        </p:spPr>
+        <p:style>
+          <a:lnRef idx="2">
+            <a:schemeClr val="accent1"/>
+          </a:lnRef>
+          <a:fillRef idx="0">
+            <a:schemeClr val="accent1"/>
+          </a:fillRef>
+          <a:effectRef idx="1">
+            <a:schemeClr val="accent1"/>
+          </a:effectRef>
+          <a:fontRef idx="minor">
+            <a:schemeClr val="tx1"/>
+          </a:fontRef>
+        </p:style>
+      </p:cxnSp>
+      <p:sp>
+        <p:nvSpPr>
+          <p:cNvPr id="19" name="TextBox 18"/>
+          <p:cNvSpPr txBox="1"/>
+          <p:nvPr/>
+        </p:nvSpPr>
+        <p:spPr>
+          <a:xfrm>
+            <a:off x="594360" y="6510528"/>
+            <a:ext cx="9509760" cy="173736"/>
+          </a:xfrm>
+          <a:prstGeom prst="rect">
+            <a:avLst/>
+          </a:prstGeom>
+          <a:noFill/>
+        </p:spPr>
+        <p:txBody>
+          <a:bodyPr wrap="square" lIns="27432" rIns="27432" tIns="27432" bIns="27432" anchor="t">
+            <a:spAutoFit/>
+          </a:bodyPr>
+          <a:lstStyle/>
+          <a:p>
+            <a:pPr algn="l">
+              <a:spcBef>
+                <a:spcPts val="0"/>
+              </a:spcBef>
+              <a:spcAft>
+                <a:spcPts val="0"/>
+              </a:spcAft>
+            </a:pPr>
+            <a:r>
+              <a:rPr sz="800" b="0">
+                <a:solidFill>
+                  <a:srgbClr val="556377"/>
+                </a:solidFill>
+                <a:latin typeface="Aptos"/>
+              </a:rPr>
+              <a:t>Source inventory: all 10 canonical RADE Success Blueprint TXT transcripts.</a:t>
+            </a:r>
+          </a:p>
+        </p:txBody>
+      </p:sp>
+      <p:sp>
+        <p:nvSpPr>
+          <p:cNvPr id="20" name="TextBox 19"/>
+          <p:cNvSpPr txBox="1"/>
+          <p:nvPr/>
+        </p:nvSpPr>
+        <p:spPr>
+          <a:xfrm>
+            <a:off x="10287000" y="6510528"/>
+            <a:ext cx="1298448" cy="173736"/>
+          </a:xfrm>
+          <a:prstGeom prst="rect">
+            <a:avLst/>
+          </a:prstGeom>
+          <a:noFill/>
+        </p:spPr>
+        <p:txBody>
+          <a:bodyPr wrap="square" lIns="27432" rIns="27432" tIns="27432" bIns="27432" anchor="t">
+            <a:spAutoFit/>
+          </a:bodyPr>
+          <a:lstStyle/>
+          <a:p>
+            <a:pPr algn="r">
+              <a:spcBef>
+                <a:spcPts val="0"/>
+              </a:spcBef>
+              <a:spcAft>
+                <a:spcPts val="0"/>
+              </a:spcAft>
+            </a:pPr>
+            <a:r>
+              <a:rPr sz="800" b="0">
+                <a:solidFill>
+                  <a:srgbClr val="556377"/>
+                </a:solidFill>
+                <a:latin typeface="Aptos"/>
+              </a:rPr>
+              <a:t>RADE Success Blueprint</a:t>
+            </a:r>
+          </a:p>
+        </p:txBody>
+      </p:sp>
+    </p:spTree>
+  </p:cSld>
+  <p:clrMapOvr>
+    <a:masterClrMapping/>
+  </p:clrMapOvr>
+</p:sld>
+</file>
+
 <file path=ppt/slides/slide2.xml><?xml version="1.0" encoding="utf-8"?>
 <p:sld xmlns:a="http://schemas.openxmlformats.org/drawingml/2006/main" xmlns:p="http://schemas.openxmlformats.org/presentationml/2006/main" xmlns:r="http://schemas.openxmlformats.org/officeDocument/2006/relationships">
   <p:cSld>
@@ -16612,6 +17653,67 @@
           </a:p>
         </p:txBody>
       </p:sp>
+      <p:sp>
+        <p:nvSpPr>
+          <p:cNvPr id="22" name="Rounded Rectangle 21"/>
+          <p:cNvSpPr/>
+          <p:nvPr/>
+        </p:nvSpPr>
+        <p:spPr>
+          <a:xfrm>
+            <a:off x="8622792" y="4773168"/>
+            <a:ext cx="2706624" cy="841248"/>
+          </a:xfrm>
+          <a:prstGeom prst="roundRect">
+            <a:avLst/>
+          </a:prstGeom>
+          <a:solidFill>
+            <a:srgbClr val="E8F7F5"/>
+          </a:solidFill>
+          <a:ln w="10160">
+            <a:solidFill>
+              <a:srgbClr val="00A7A5"/>
+            </a:solidFill>
+          </a:ln>
+        </p:spPr>
+        <p:style>
+          <a:lnRef idx="1">
+            <a:schemeClr val="accent1"/>
+          </a:lnRef>
+          <a:fillRef idx="3">
+            <a:schemeClr val="accent1"/>
+          </a:fillRef>
+          <a:effectRef idx="2">
+            <a:schemeClr val="accent1"/>
+          </a:effectRef>
+          <a:fontRef idx="minor">
+            <a:schemeClr val="lt1"/>
+          </a:fontRef>
+        </p:style>
+        <p:txBody>
+          <a:bodyPr rtlCol="0" anchor="ctr" wrap="square" lIns="118872" rIns="118872" tIns="27432" bIns="27432"/>
+          <a:lstStyle/>
+          <a:p>
+            <a:pPr algn="ctr">
+              <a:spcBef>
+                <a:spcPts val="0"/>
+              </a:spcBef>
+              <a:spcAft>
+                <a:spcPts val="0"/>
+              </a:spcAft>
+            </a:pPr>
+            <a:r>
+              <a:rPr sz="1140" b="1">
+                <a:solidFill>
+                  <a:srgbClr val="0B1F33"/>
+                </a:solidFill>
+                <a:latin typeface="Aptos"/>
+              </a:rPr>
+              <a:t>Instructor practice: contribute monthly to a cause you value.</a:t>
+            </a:r>
+          </a:p>
+        </p:txBody>
+      </p:sp>
     </p:spTree>
   </p:cSld>
   <p:clrMapOvr>
@@ -17271,21 +18373,27 @@
         </p:nvSpPr>
         <p:spPr>
           <a:xfrm>
-            <a:off x="859536" y="5751576"/>
-            <a:ext cx="6949440" cy="219456"/>
-          </a:xfrm>
-          <a:prstGeom prst="rect">
-            <a:avLst/>
-          </a:prstGeom>
-          <a:noFill/>
-        </p:spPr>
-        <p:txBody>
-          <a:bodyPr wrap="square" anchor="t" lIns="36576" rIns="36576" tIns="36576" bIns="36576">
-            <a:spAutoFit/>
-          </a:bodyPr>
-          <a:lstStyle/>
-          <a:p>
-            <a:pPr algn="l">
+            <a:off x="694944" y="5504688"/>
+            <a:ext cx="10890504" cy="566928"/>
+          </a:xfrm>
+          <a:prstGeom prst="rect">
+            <a:avLst/>
+          </a:prstGeom>
+          <a:noFill/>
+        </p:spPr>
+        <p:txBody>
+          <a:bodyPr wrap="square" anchor="ctr" lIns="73152" rIns="73152" tIns="73152" bIns="73152">
+            <a:spAutoFit/>
+          </a:bodyPr>
+          <a:lstStyle/>
+          <a:p>
+            <a:pPr algn="ctr">
+              <a:spcBef>
+                <a:spcPts val="0"/>
+              </a:spcBef>
+              <a:spcAft>
+                <a:spcPts val="0"/>
+              </a:spcAft>
               <a:defRPr sz="900" b="1">
                 <a:solidFill>
                   <a:srgbClr val="77500F"/>
@@ -17294,7 +18402,13 @@
               </a:defRPr>
             </a:pPr>
             <a:r>
-              <a:t>Participant testimonials are course examples, not independently verified or guaranteed outcomes.</a:t>
+              <a:rPr sz="940" b="1">
+                <a:solidFill>
+                  <a:srgbClr val="14233E"/>
+                </a:solidFill>
+                <a:latin typeface="Aptos"/>
+              </a:rPr>
+              <a:t>Source includes a participant assertion of multiple offers within three months. This assertion is not independently verified, typical, or guaranteed.</a:t>
             </a:r>
           </a:p>
         </p:txBody>

</xml_diff>